<commit_message>
Sunuma Platformlar & İndirme slaydı eklendi (v0.1.0 GitHub sürümü)
TR ve EN destelere Windows 10/11 (x64) + macOS (Apple Silicon) platform
bilgisi, herkese açık GitHub deposu ve v0.1.0 Releases indirme bağlantısı
eklendi; macOS paketinin notarize edilmediğine dair tek cümlelik dipnot
kondu. Tüm sunum çıktıları (HTML/PPTX/PDF) yeniden üretildi.

Co-Authored-By: Claude Fable 5 <noreply@anthropic.com>
</commit_message>
<xml_diff>
--- a/docs/presentation/Wine_House_Intro_EN_PUBLIC.pptx
+++ b/docs/presentation/Wine_House_Intro_EN_PUBLIC.pptx
@@ -62,6 +62,7 @@
     <p:sldId id="310" r:id="rId61"/>
     <p:sldId id="311" r:id="rId62"/>
     <p:sldId id="312" r:id="rId63"/>
+    <p:sldId id="313" r:id="rId64"/>
   </p:sldIdLst>
   <p:sldSz cx="12191969" cy="6858000" type="screen4x3"/>
   <p:notesSz cx="6858000" cy="9144000"/>
@@ -5827,7 +5828,7 @@
                 </a:solidFill>
                 <a:latin typeface="DejaVu Sans"/>
               </a:rPr>
-              <a:t>13 / 57</a:t>
+              <a:t>13 / 58</a:t>
             </a:r>
           </a:p>
         </p:txBody>
@@ -13678,7 +13679,7 @@
                 </a:solidFill>
                 <a:latin typeface="DejaVu Sans"/>
               </a:rPr>
-              <a:t>22 / 57</a:t>
+              <a:t>22 / 58</a:t>
             </a:r>
           </a:p>
         </p:txBody>
@@ -18057,7 +18058,7 @@
                 </a:solidFill>
                 <a:latin typeface="DejaVu Sans"/>
               </a:rPr>
-              <a:t>27 / 57</a:t>
+              <a:t>27 / 58</a:t>
             </a:r>
           </a:p>
         </p:txBody>
@@ -22195,7 +22196,7 @@
                 </a:solidFill>
                 <a:latin typeface="DejaVu Sans"/>
               </a:rPr>
-              <a:t>31 / 57</a:t>
+              <a:t>31 / 58</a:t>
             </a:r>
           </a:p>
         </p:txBody>
@@ -24806,7 +24807,7 @@
                 </a:solidFill>
                 <a:latin typeface="DejaVu Sans"/>
               </a:rPr>
-              <a:t>35 / 57</a:t>
+              <a:t>35 / 58</a:t>
             </a:r>
           </a:p>
         </p:txBody>
@@ -31747,7 +31748,7 @@
                 </a:solidFill>
                 <a:latin typeface="DejaVu Sans"/>
               </a:rPr>
-              <a:t>An honest status report</a:t>
+              <a:t>Platforms &amp; Download</a:t>
             </a:r>
           </a:p>
           <a:p>
@@ -31763,7 +31764,7 @@
                 </a:solidFill>
                 <a:latin typeface="DejaVu Sans"/>
               </a:rPr>
-              <a:t>No unfinished feature is presented as finished</a:t>
+              <a:t>Public GitHub repository and ready-made packages</a:t>
             </a:r>
           </a:p>
         </p:txBody>
@@ -31814,388 +31815,14 @@
       </p:sp>
       <p:sp>
         <p:nvSpPr>
-          <p:cNvPr id="4" name="Rounded Rectangle 3"/>
+          <p:cNvPr id="4" name="Rectangle 3"/>
           <p:cNvSpPr/>
           <p:nvPr/>
         </p:nvSpPr>
         <p:spPr>
           <a:xfrm>
-            <a:off x="777240" y="1965960"/>
-            <a:ext cx="4919472" cy="3657600"/>
-          </a:xfrm>
-          <a:prstGeom prst="roundRect">
-            <a:avLst>
-              <a:gd name="adj" fmla="val 6000"/>
-            </a:avLst>
-          </a:prstGeom>
-          <a:solidFill>
-            <a:srgbClr val="241419"/>
-          </a:solidFill>
-          <a:ln w="12700">
-            <a:solidFill>
-              <a:srgbClr val="3D2530"/>
-            </a:solidFill>
-          </a:ln>
-          <a:effectLst/>
-        </p:spPr>
-        <p:style>
-          <a:lnRef idx="1">
-            <a:schemeClr val="accent1"/>
-          </a:lnRef>
-          <a:fillRef idx="3">
-            <a:schemeClr val="accent1"/>
-          </a:fillRef>
-          <a:effectRef idx="2">
-            <a:schemeClr val="accent1"/>
-          </a:effectRef>
-          <a:fontRef idx="minor">
-            <a:schemeClr val="lt1"/>
-          </a:fontRef>
-        </p:style>
-        <p:txBody>
-          <a:bodyPr rtlCol="0" anchor="ctr"/>
-          <a:lstStyle/>
-          <a:p>
-            <a:pPr algn="ctr"/>
-          </a:p>
-        </p:txBody>
-      </p:sp>
-      <p:sp>
-        <p:nvSpPr>
-          <p:cNvPr id="5" name="Rectangle 4"/>
-          <p:cNvSpPr/>
-          <p:nvPr/>
-        </p:nvSpPr>
-        <p:spPr>
-          <a:xfrm>
-            <a:off x="777240" y="1965960"/>
-            <a:ext cx="4919472" cy="50800"/>
-          </a:xfrm>
-          <a:prstGeom prst="rect">
-            <a:avLst/>
-          </a:prstGeom>
-          <a:solidFill>
-            <a:srgbClr val="9B4B6B"/>
-          </a:solidFill>
-          <a:ln>
-            <a:noFill/>
-          </a:ln>
-          <a:effectLst/>
-        </p:spPr>
-        <p:style>
-          <a:lnRef idx="1">
-            <a:schemeClr val="accent1"/>
-          </a:lnRef>
-          <a:fillRef idx="3">
-            <a:schemeClr val="accent1"/>
-          </a:fillRef>
-          <a:effectRef idx="2">
-            <a:schemeClr val="accent1"/>
-          </a:effectRef>
-          <a:fontRef idx="minor">
-            <a:schemeClr val="lt1"/>
-          </a:fontRef>
-        </p:style>
-        <p:txBody>
-          <a:bodyPr rtlCol="0" anchor="ctr"/>
-          <a:lstStyle/>
-          <a:p>
-            <a:pPr algn="ctr"/>
-          </a:p>
-        </p:txBody>
-      </p:sp>
-      <p:sp>
-        <p:nvSpPr>
-          <p:cNvPr id="6" name="TextBox 5"/>
-          <p:cNvSpPr txBox="1"/>
-          <p:nvPr/>
-        </p:nvSpPr>
-        <p:spPr>
-          <a:xfrm>
-            <a:off x="1051560" y="2212848"/>
-            <a:ext cx="4389120" cy="457200"/>
-          </a:xfrm>
-          <a:prstGeom prst="rect">
-            <a:avLst/>
-          </a:prstGeom>
-          <a:noFill/>
-        </p:spPr>
-        <p:txBody>
-          <a:bodyPr wrap="square" anchor="t" lIns="0" rIns="0" tIns="0" bIns="0">
-            <a:spAutoFit/>
-          </a:bodyPr>
-          <a:lstStyle/>
-          <a:p>
-            <a:pPr algn="l">
-              <a:spcAft>
-                <a:spcPts val="0"/>
-              </a:spcAft>
-            </a:pPr>
-            <a:r>
-              <a:rPr sz="1500" b="1">
-                <a:solidFill>
-                  <a:srgbClr val="C8A45C"/>
-                </a:solidFill>
-                <a:latin typeface="DejaVu Sans"/>
-              </a:rPr>
-              <a:t>Ready and working</a:t>
-            </a:r>
-          </a:p>
-        </p:txBody>
-      </p:sp>
-      <p:sp>
-        <p:nvSpPr>
-          <p:cNvPr id="7" name="TextBox 6"/>
-          <p:cNvSpPr txBox="1"/>
-          <p:nvPr/>
-        </p:nvSpPr>
-        <p:spPr>
-          <a:xfrm>
-            <a:off x="1051560" y="2761488"/>
-            <a:ext cx="4434840" cy="566928"/>
-          </a:xfrm>
-          <a:prstGeom prst="rect">
-            <a:avLst/>
-          </a:prstGeom>
-          <a:noFill/>
-        </p:spPr>
-        <p:txBody>
-          <a:bodyPr wrap="square" anchor="t" lIns="0" rIns="0" tIns="0" bIns="0">
-            <a:spAutoFit/>
-          </a:bodyPr>
-          <a:lstStyle/>
-          <a:p>
-            <a:pPr algn="l">
-              <a:spcAft>
-                <a:spcPts val="0"/>
-              </a:spcAft>
-            </a:pPr>
-            <a:r>
-              <a:rPr sz="1250" b="0">
-                <a:solidFill>
-                  <a:srgbClr val="F2EAEC"/>
-                </a:solidFill>
-                <a:latin typeface="DejaVu Sans"/>
-              </a:rPr>
-              <a:t>·  Floor operations · KDS · payment · day close</a:t>
-            </a:r>
-          </a:p>
-        </p:txBody>
-      </p:sp>
-      <p:sp>
-        <p:nvSpPr>
-          <p:cNvPr id="8" name="TextBox 7"/>
-          <p:cNvSpPr txBox="1"/>
-          <p:nvPr/>
-        </p:nvSpPr>
-        <p:spPr>
-          <a:xfrm>
-            <a:off x="1051560" y="3328416"/>
-            <a:ext cx="4434840" cy="566928"/>
-          </a:xfrm>
-          <a:prstGeom prst="rect">
-            <a:avLst/>
-          </a:prstGeom>
-          <a:noFill/>
-        </p:spPr>
-        <p:txBody>
-          <a:bodyPr wrap="square" anchor="t" lIns="0" rIns="0" tIns="0" bIns="0">
-            <a:spAutoFit/>
-          </a:bodyPr>
-          <a:lstStyle/>
-          <a:p>
-            <a:pPr algn="l">
-              <a:spcAft>
-                <a:spcPts val="0"/>
-              </a:spcAft>
-            </a:pPr>
-            <a:r>
-              <a:rPr sz="1250" b="0">
-                <a:solidFill>
-                  <a:srgbClr val="F2EAEC"/>
-                </a:solidFill>
-                <a:latin typeface="DejaVu Sans"/>
-              </a:rPr>
-              <a:t>·  Wine cellar · by-the-glass service · yield analysis</a:t>
-            </a:r>
-          </a:p>
-        </p:txBody>
-      </p:sp>
-      <p:sp>
-        <p:nvSpPr>
-          <p:cNvPr id="9" name="TextBox 8"/>
-          <p:cNvSpPr txBox="1"/>
-          <p:nvPr/>
-        </p:nvSpPr>
-        <p:spPr>
-          <a:xfrm>
-            <a:off x="1051560" y="3895344"/>
-            <a:ext cx="4434840" cy="566928"/>
-          </a:xfrm>
-          <a:prstGeom prst="rect">
-            <a:avLst/>
-          </a:prstGeom>
-          <a:noFill/>
-        </p:spPr>
-        <p:txBody>
-          <a:bodyPr wrap="square" anchor="t" lIns="0" rIns="0" tIns="0" bIns="0">
-            <a:spAutoFit/>
-          </a:bodyPr>
-          <a:lstStyle/>
-          <a:p>
-            <a:pPr algn="l">
-              <a:spcAft>
-                <a:spcPts val="0"/>
-              </a:spcAft>
-            </a:pPr>
-            <a:r>
-              <a:rPr sz="1250" b="0">
-                <a:solidFill>
-                  <a:srgbClr val="F2EAEC"/>
-                </a:solidFill>
-                <a:latin typeface="DejaVu Sans"/>
-              </a:rPr>
-              <a:t>·  Inventory · purchasing · waste · stock counts</a:t>
-            </a:r>
-          </a:p>
-        </p:txBody>
-      </p:sp>
-      <p:sp>
-        <p:nvSpPr>
-          <p:cNvPr id="10" name="TextBox 9"/>
-          <p:cNvSpPr txBox="1"/>
-          <p:nvPr/>
-        </p:nvSpPr>
-        <p:spPr>
-          <a:xfrm>
-            <a:off x="1051560" y="4462272"/>
-            <a:ext cx="4434840" cy="566928"/>
-          </a:xfrm>
-          <a:prstGeom prst="rect">
-            <a:avLst/>
-          </a:prstGeom>
-          <a:noFill/>
-        </p:spPr>
-        <p:txBody>
-          <a:bodyPr wrap="square" anchor="t" lIns="0" rIns="0" tIns="0" bIns="0">
-            <a:spAutoFit/>
-          </a:bodyPr>
-          <a:lstStyle/>
-          <a:p>
-            <a:pPr algn="l">
-              <a:spcAft>
-                <a:spcPts val="0"/>
-              </a:spcAft>
-            </a:pPr>
-            <a:r>
-              <a:rPr sz="1250" b="0">
-                <a:solidFill>
-                  <a:srgbClr val="F2EAEC"/>
-                </a:solidFill>
-                <a:latin typeface="DejaVu Sans"/>
-              </a:rPr>
-              <a:t>·  CRM · GDPR · staff · 13 reports</a:t>
-            </a:r>
-          </a:p>
-        </p:txBody>
-      </p:sp>
-      <p:sp>
-        <p:nvSpPr>
-          <p:cNvPr id="11" name="TextBox 10"/>
-          <p:cNvSpPr txBox="1"/>
-          <p:nvPr/>
-        </p:nvSpPr>
-        <p:spPr>
-          <a:xfrm>
-            <a:off x="1051560" y="5029200"/>
-            <a:ext cx="4434840" cy="566928"/>
-          </a:xfrm>
-          <a:prstGeom prst="rect">
-            <a:avLst/>
-          </a:prstGeom>
-          <a:noFill/>
-        </p:spPr>
-        <p:txBody>
-          <a:bodyPr wrap="square" anchor="t" lIns="0" rIns="0" tIns="0" bIns="0">
-            <a:spAutoFit/>
-          </a:bodyPr>
-          <a:lstStyle/>
-          <a:p>
-            <a:pPr algn="l">
-              <a:spcAft>
-                <a:spcPts val="0"/>
-              </a:spcAft>
-            </a:pPr>
-            <a:r>
-              <a:rPr sz="1250" b="0">
-                <a:solidFill>
-                  <a:srgbClr val="F2EAEC"/>
-                </a:solidFill>
-                <a:latin typeface="DejaVu Sans"/>
-              </a:rPr>
-              <a:t>·  AI layer · backups · 19 roles</a:t>
-            </a:r>
-          </a:p>
-        </p:txBody>
-      </p:sp>
-      <p:sp>
-        <p:nvSpPr>
-          <p:cNvPr id="12" name="Rounded Rectangle 11"/>
-          <p:cNvSpPr/>
-          <p:nvPr/>
-        </p:nvSpPr>
-        <p:spPr>
-          <a:xfrm>
-            <a:off x="6492240" y="1965960"/>
-            <a:ext cx="4919472" cy="3657600"/>
-          </a:xfrm>
-          <a:prstGeom prst="roundRect">
-            <a:avLst>
-              <a:gd name="adj" fmla="val 6000"/>
-            </a:avLst>
-          </a:prstGeom>
-          <a:solidFill>
-            <a:srgbClr val="241419"/>
-          </a:solidFill>
-          <a:ln w="12700">
-            <a:solidFill>
-              <a:srgbClr val="3D2530"/>
-            </a:solidFill>
-          </a:ln>
-          <a:effectLst/>
-        </p:spPr>
-        <p:style>
-          <a:lnRef idx="1">
-            <a:schemeClr val="accent1"/>
-          </a:lnRef>
-          <a:fillRef idx="3">
-            <a:schemeClr val="accent1"/>
-          </a:fillRef>
-          <a:effectRef idx="2">
-            <a:schemeClr val="accent1"/>
-          </a:effectRef>
-          <a:fontRef idx="minor">
-            <a:schemeClr val="lt1"/>
-          </a:fontRef>
-        </p:style>
-        <p:txBody>
-          <a:bodyPr rtlCol="0" anchor="ctr"/>
-          <a:lstStyle/>
-          <a:p>
-            <a:pPr algn="ctr"/>
-          </a:p>
-        </p:txBody>
-      </p:sp>
-      <p:sp>
-        <p:nvSpPr>
-          <p:cNvPr id="13" name="Rectangle 12"/>
-          <p:cNvSpPr/>
-          <p:nvPr/>
-        </p:nvSpPr>
-        <p:spPr>
-          <a:xfrm>
-            <a:off x="6492240" y="1965960"/>
-            <a:ext cx="4919472" cy="50800"/>
+            <a:off x="822960" y="2150303"/>
+            <a:ext cx="76200" cy="76200"/>
           </a:xfrm>
           <a:prstGeom prst="rect">
             <a:avLst/>
@@ -32232,280 +31859,275 @@
       </p:sp>
       <p:sp>
         <p:nvSpPr>
-          <p:cNvPr id="14" name="TextBox 13"/>
-          <p:cNvSpPr txBox="1"/>
-          <p:nvPr/>
-        </p:nvSpPr>
-        <p:spPr>
-          <a:xfrm>
-            <a:off x="6766559" y="2212848"/>
-            <a:ext cx="4389120" cy="457200"/>
-          </a:xfrm>
-          <a:prstGeom prst="rect">
-            <a:avLst/>
-          </a:prstGeom>
-          <a:noFill/>
-        </p:spPr>
-        <p:txBody>
-          <a:bodyPr wrap="square" anchor="t" lIns="0" rIns="0" tIns="0" bIns="0">
-            <a:spAutoFit/>
-          </a:bodyPr>
-          <a:lstStyle/>
-          <a:p>
-            <a:pPr algn="l">
-              <a:spcAft>
-                <a:spcPts val="0"/>
-              </a:spcAft>
-            </a:pPr>
-            <a:r>
-              <a:rPr sz="1500" b="1">
+          <p:cNvPr id="5" name="TextBox 4"/>
+          <p:cNvSpPr txBox="1"/>
+          <p:nvPr/>
+        </p:nvSpPr>
+        <p:spPr>
+          <a:xfrm>
+            <a:off x="1170432" y="1965960"/>
+            <a:ext cx="10241280" cy="658368"/>
+          </a:xfrm>
+          <a:prstGeom prst="rect">
+            <a:avLst/>
+          </a:prstGeom>
+          <a:noFill/>
+        </p:spPr>
+        <p:txBody>
+          <a:bodyPr wrap="square" anchor="t" lIns="0" rIns="0" tIns="0" bIns="0">
+            <a:spAutoFit/>
+          </a:bodyPr>
+          <a:lstStyle/>
+          <a:p>
+            <a:pPr algn="l">
+              <a:spcAft>
+                <a:spcPts val="0"/>
+              </a:spcAft>
+            </a:pPr>
+            <a:r>
+              <a:rPr sz="1600" b="1">
                 <a:solidFill>
                   <a:srgbClr val="C8A45C"/>
                 </a:solidFill>
                 <a:latin typeface="DejaVu Sans"/>
               </a:rPr>
-              <a:t>Experimental or planned</a:t>
-            </a:r>
-          </a:p>
-        </p:txBody>
-      </p:sp>
-      <p:sp>
-        <p:nvSpPr>
-          <p:cNvPr id="15" name="TextBox 14"/>
-          <p:cNvSpPr txBox="1"/>
-          <p:nvPr/>
-        </p:nvSpPr>
-        <p:spPr>
-          <a:xfrm>
-            <a:off x="6766559" y="2761488"/>
-            <a:ext cx="4434840" cy="566928"/>
-          </a:xfrm>
-          <a:prstGeom prst="rect">
-            <a:avLst/>
-          </a:prstGeom>
-          <a:noFill/>
-        </p:spPr>
-        <p:txBody>
-          <a:bodyPr wrap="square" anchor="t" lIns="0" rIns="0" tIns="0" bIns="0">
-            <a:spAutoFit/>
-          </a:bodyPr>
-          <a:lstStyle/>
-          <a:p>
-            <a:pPr algn="l">
-              <a:spcAft>
-                <a:spcPts val="0"/>
-              </a:spcAft>
-            </a:pPr>
-            <a:r>
-              <a:rPr sz="1250" b="0">
+              <a:t>Windows 10/11 (x64)</a:t>
+            </a:r>
+            <a:r>
+              <a:rPr sz="1600" b="0">
                 <a:solidFill>
                   <a:srgbClr val="F2EAEC"/>
                 </a:solidFill>
                 <a:latin typeface="DejaVu Sans"/>
               </a:rPr>
-              <a:t>·  Live payment and e-invoicing (adapter only)</a:t>
-            </a:r>
-          </a:p>
-        </p:txBody>
-      </p:sp>
-      <p:sp>
-        <p:nvSpPr>
-          <p:cNvPr id="16" name="TextBox 15"/>
-          <p:cNvSpPr txBox="1"/>
-          <p:nvPr/>
-        </p:nvSpPr>
-        <p:spPr>
-          <a:xfrm>
-            <a:off x="6766559" y="3328416"/>
-            <a:ext cx="4434840" cy="566928"/>
-          </a:xfrm>
-          <a:prstGeom prst="rect">
-            <a:avLst/>
-          </a:prstGeom>
-          <a:noFill/>
-        </p:spPr>
-        <p:txBody>
-          <a:bodyPr wrap="square" anchor="t" lIns="0" rIns="0" tIns="0" bIns="0">
-            <a:spAutoFit/>
-          </a:bodyPr>
-          <a:lstStyle/>
-          <a:p>
-            <a:pPr algn="l">
-              <a:spcAft>
-                <a:spcPts val="0"/>
-              </a:spcAft>
-            </a:pPr>
-            <a:r>
-              <a:rPr sz="1250" b="0">
+              <a:t> &amp; </a:t>
+            </a:r>
+            <a:r>
+              <a:rPr sz="1600" b="1">
+                <a:solidFill>
+                  <a:srgbClr val="C8A45C"/>
+                </a:solidFill>
+                <a:latin typeface="DejaVu Sans"/>
+              </a:rPr>
+              <a:t>macOS (Apple Silicon)</a:t>
+            </a:r>
+            <a:r>
+              <a:rPr sz="1600" b="0">
                 <a:solidFill>
                   <a:srgbClr val="F2EAEC"/>
                 </a:solidFill>
                 <a:latin typeface="DejaVu Sans"/>
               </a:rPr>
-              <a:t>·  Thermal printer driver</a:t>
-            </a:r>
-          </a:p>
-        </p:txBody>
-      </p:sp>
-      <p:sp>
-        <p:nvSpPr>
-          <p:cNvPr id="17" name="TextBox 16"/>
-          <p:cNvSpPr txBox="1"/>
-          <p:nvPr/>
-        </p:nvSpPr>
-        <p:spPr>
-          <a:xfrm>
-            <a:off x="6766559" y="3895344"/>
-            <a:ext cx="4434840" cy="566928"/>
-          </a:xfrm>
-          <a:prstGeom prst="rect">
-            <a:avLst/>
-          </a:prstGeom>
-          <a:noFill/>
-        </p:spPr>
-        <p:txBody>
-          <a:bodyPr wrap="square" anchor="t" lIns="0" rIns="0" tIns="0" bIns="0">
-            <a:spAutoFit/>
-          </a:bodyPr>
-          <a:lstStyle/>
-          <a:p>
-            <a:pPr algn="l">
-              <a:spcAft>
-                <a:spcPts val="0"/>
-              </a:spcAft>
-            </a:pPr>
-            <a:r>
-              <a:rPr sz="1250" b="0">
+              <a:t> — Download: GitHub Releases (v0.1.0)</a:t>
+            </a:r>
+          </a:p>
+        </p:txBody>
+      </p:sp>
+      <p:sp>
+        <p:nvSpPr>
+          <p:cNvPr id="6" name="Rectangle 5"/>
+          <p:cNvSpPr/>
+          <p:nvPr/>
+        </p:nvSpPr>
+        <p:spPr>
+          <a:xfrm>
+            <a:off x="822960" y="2808671"/>
+            <a:ext cx="76200" cy="76200"/>
+          </a:xfrm>
+          <a:prstGeom prst="rect">
+            <a:avLst/>
+          </a:prstGeom>
+          <a:solidFill>
+            <a:srgbClr val="C8A45C"/>
+          </a:solidFill>
+          <a:ln>
+            <a:noFill/>
+          </a:ln>
+          <a:effectLst/>
+        </p:spPr>
+        <p:style>
+          <a:lnRef idx="1">
+            <a:schemeClr val="accent1"/>
+          </a:lnRef>
+          <a:fillRef idx="3">
+            <a:schemeClr val="accent1"/>
+          </a:fillRef>
+          <a:effectRef idx="2">
+            <a:schemeClr val="accent1"/>
+          </a:effectRef>
+          <a:fontRef idx="minor">
+            <a:schemeClr val="lt1"/>
+          </a:fontRef>
+        </p:style>
+        <p:txBody>
+          <a:bodyPr rtlCol="0" anchor="ctr"/>
+          <a:lstStyle/>
+          <a:p>
+            <a:pPr algn="ctr"/>
+          </a:p>
+        </p:txBody>
+      </p:sp>
+      <p:sp>
+        <p:nvSpPr>
+          <p:cNvPr id="7" name="TextBox 6"/>
+          <p:cNvSpPr txBox="1"/>
+          <p:nvPr/>
+        </p:nvSpPr>
+        <p:spPr>
+          <a:xfrm>
+            <a:off x="1170432" y="2624328"/>
+            <a:ext cx="10241280" cy="658368"/>
+          </a:xfrm>
+          <a:prstGeom prst="rect">
+            <a:avLst/>
+          </a:prstGeom>
+          <a:noFill/>
+        </p:spPr>
+        <p:txBody>
+          <a:bodyPr wrap="square" anchor="t" lIns="0" rIns="0" tIns="0" bIns="0">
+            <a:spAutoFit/>
+          </a:bodyPr>
+          <a:lstStyle/>
+          <a:p>
+            <a:pPr algn="l">
+              <a:spcAft>
+                <a:spcPts val="0"/>
+              </a:spcAft>
+            </a:pPr>
+            <a:r>
+              <a:rPr sz="1600" b="1">
+                <a:solidFill>
+                  <a:srgbClr val="C8A45C"/>
+                </a:solidFill>
+                <a:latin typeface="DejaVu Sans"/>
+              </a:rPr>
+              <a:t>Public</a:t>
+            </a:r>
+            <a:r>
+              <a:rPr sz="1600" b="0">
                 <a:solidFill>
                   <a:srgbClr val="F2EAEC"/>
                 </a:solidFill>
                 <a:latin typeface="DejaVu Sans"/>
               </a:rPr>
-              <a:t>·  Bulk email/SMS dispatch</a:t>
-            </a:r>
-          </a:p>
-        </p:txBody>
-      </p:sp>
-      <p:sp>
-        <p:nvSpPr>
-          <p:cNvPr id="18" name="TextBox 17"/>
-          <p:cNvSpPr txBox="1"/>
-          <p:nvPr/>
-        </p:nvSpPr>
-        <p:spPr>
-          <a:xfrm>
-            <a:off x="6766559" y="4462272"/>
-            <a:ext cx="4434840" cy="566928"/>
-          </a:xfrm>
-          <a:prstGeom prst="rect">
-            <a:avLst/>
-          </a:prstGeom>
-          <a:noFill/>
-        </p:spPr>
-        <p:txBody>
-          <a:bodyPr wrap="square" anchor="t" lIns="0" rIns="0" tIns="0" bIns="0">
-            <a:spAutoFit/>
-          </a:bodyPr>
-          <a:lstStyle/>
-          <a:p>
-            <a:pPr algn="l">
-              <a:spcAft>
-                <a:spcPts val="0"/>
-              </a:spcAft>
-            </a:pPr>
-            <a:r>
-              <a:rPr sz="1250" b="0">
+              <a:t> GitHub repository: github.com/Azizsekerdil/smart-wine-restaurant-management-system</a:t>
+            </a:r>
+          </a:p>
+        </p:txBody>
+      </p:sp>
+      <p:sp>
+        <p:nvSpPr>
+          <p:cNvPr id="8" name="Rectangle 7"/>
+          <p:cNvSpPr/>
+          <p:nvPr/>
+        </p:nvSpPr>
+        <p:spPr>
+          <a:xfrm>
+            <a:off x="822960" y="3467039"/>
+            <a:ext cx="76200" cy="76200"/>
+          </a:xfrm>
+          <a:prstGeom prst="rect">
+            <a:avLst/>
+          </a:prstGeom>
+          <a:solidFill>
+            <a:srgbClr val="C8A45C"/>
+          </a:solidFill>
+          <a:ln>
+            <a:noFill/>
+          </a:ln>
+          <a:effectLst/>
+        </p:spPr>
+        <p:style>
+          <a:lnRef idx="1">
+            <a:schemeClr val="accent1"/>
+          </a:lnRef>
+          <a:fillRef idx="3">
+            <a:schemeClr val="accent1"/>
+          </a:fillRef>
+          <a:effectRef idx="2">
+            <a:schemeClr val="accent1"/>
+          </a:effectRef>
+          <a:fontRef idx="minor">
+            <a:schemeClr val="lt1"/>
+          </a:fontRef>
+        </p:style>
+        <p:txBody>
+          <a:bodyPr rtlCol="0" anchor="ctr"/>
+          <a:lstStyle/>
+          <a:p>
+            <a:pPr algn="ctr"/>
+          </a:p>
+        </p:txBody>
+      </p:sp>
+      <p:sp>
+        <p:nvSpPr>
+          <p:cNvPr id="9" name="TextBox 8"/>
+          <p:cNvSpPr txBox="1"/>
+          <p:nvPr/>
+        </p:nvSpPr>
+        <p:spPr>
+          <a:xfrm>
+            <a:off x="1170432" y="3282696"/>
+            <a:ext cx="10241280" cy="658368"/>
+          </a:xfrm>
+          <a:prstGeom prst="rect">
+            <a:avLst/>
+          </a:prstGeom>
+          <a:noFill/>
+        </p:spPr>
+        <p:txBody>
+          <a:bodyPr wrap="square" anchor="t" lIns="0" rIns="0" tIns="0" bIns="0">
+            <a:spAutoFit/>
+          </a:bodyPr>
+          <a:lstStyle/>
+          <a:p>
+            <a:pPr algn="l">
+              <a:spcAft>
+                <a:spcPts val="0"/>
+              </a:spcAft>
+            </a:pPr>
+            <a:r>
+              <a:rPr sz="1600" b="0">
                 <a:solidFill>
                   <a:srgbClr val="F2EAEC"/>
                 </a:solidFill>
                 <a:latin typeface="DejaVu Sans"/>
               </a:rPr>
-              <a:t>·  Cellar sensor integration</a:t>
-            </a:r>
-          </a:p>
-        </p:txBody>
-      </p:sp>
-      <p:sp>
-        <p:nvSpPr>
-          <p:cNvPr id="19" name="TextBox 18"/>
-          <p:cNvSpPr txBox="1"/>
-          <p:nvPr/>
-        </p:nvSpPr>
-        <p:spPr>
-          <a:xfrm>
-            <a:off x="6766559" y="5029200"/>
-            <a:ext cx="4434840" cy="566928"/>
-          </a:xfrm>
-          <a:prstGeom prst="rect">
-            <a:avLst/>
-          </a:prstGeom>
-          <a:noFill/>
-        </p:spPr>
-        <p:txBody>
-          <a:bodyPr wrap="square" anchor="t" lIns="0" rIns="0" tIns="0" bIns="0">
-            <a:spAutoFit/>
-          </a:bodyPr>
-          <a:lstStyle/>
-          <a:p>
-            <a:pPr algn="l">
-              <a:spcAft>
-                <a:spcPts val="0"/>
-              </a:spcAft>
-            </a:pPr>
-            <a:r>
-              <a:rPr sz="1250" b="0">
+              <a:t>Release v0.1.0 ships two packages: </a:t>
+            </a:r>
+            <a:r>
+              <a:rPr sz="1600" b="1">
+                <a:solidFill>
+                  <a:srgbClr val="C8A45C"/>
+                </a:solidFill>
+                <a:latin typeface="DejaVu Sans"/>
+              </a:rPr>
+              <a:t>Windows ZIP</a:t>
+            </a:r>
+            <a:r>
+              <a:rPr sz="1600" b="0">
                 <a:solidFill>
                   <a:srgbClr val="F2EAEC"/>
                 </a:solidFill>
                 <a:latin typeface="DejaVu Sans"/>
               </a:rPr>
-              <a:t>·  Label image analysis · multi-terminal sync</a:t>
-            </a:r>
-          </a:p>
-        </p:txBody>
-      </p:sp>
-      <p:sp>
-        <p:nvSpPr>
-          <p:cNvPr id="20" name="TextBox 19"/>
-          <p:cNvSpPr txBox="1"/>
-          <p:nvPr/>
-        </p:nvSpPr>
-        <p:spPr>
-          <a:xfrm>
-            <a:off x="777240" y="5779008"/>
-            <a:ext cx="10607040" cy="457200"/>
-          </a:xfrm>
-          <a:prstGeom prst="rect">
-            <a:avLst/>
-          </a:prstGeom>
-          <a:noFill/>
-        </p:spPr>
-        <p:txBody>
-          <a:bodyPr wrap="square" anchor="t" lIns="0" rIns="0" tIns="0" bIns="0">
-            <a:spAutoFit/>
-          </a:bodyPr>
-          <a:lstStyle/>
-          <a:p>
-            <a:pPr algn="l">
-              <a:spcAft>
-                <a:spcPts val="0"/>
-              </a:spcAft>
-            </a:pPr>
-            <a:r>
-              <a:rPr sz="1100" b="0">
-                <a:solidFill>
-                  <a:srgbClr val="B9A7AE"/>
-                </a:solidFill>
-                <a:latin typeface="DejaVu Sans"/>
-              </a:rPr>
-              <a:t>Every feature carries a badge in the application: Ready · Experimental · Planned</a:t>
-            </a:r>
-          </a:p>
-        </p:txBody>
-      </p:sp>
-      <p:sp>
-        <p:nvSpPr>
-          <p:cNvPr id="21" name="TextBox 20"/>
+              <a:t> + </a:t>
+            </a:r>
+            <a:r>
+              <a:rPr sz="1600" b="1">
+                <a:solidFill>
+                  <a:srgbClr val="C8A45C"/>
+                </a:solidFill>
+                <a:latin typeface="DejaVu Sans"/>
+              </a:rPr>
+              <a:t>macOS ZIP</a:t>
+            </a:r>
+          </a:p>
+        </p:txBody>
+      </p:sp>
+      <p:sp>
+        <p:nvSpPr>
+          <p:cNvPr id="10" name="TextBox 9"/>
           <p:cNvSpPr txBox="1"/>
           <p:nvPr/>
         </p:nvSpPr>
@@ -32544,7 +32166,7 @@
       </p:sp>
       <p:sp>
         <p:nvSpPr>
-          <p:cNvPr id="22" name="TextBox 21"/>
+          <p:cNvPr id="11" name="TextBox 10"/>
           <p:cNvSpPr txBox="1"/>
           <p:nvPr/>
         </p:nvSpPr>
@@ -32609,45 +32231,56 @@
       <p:grpSpPr/>
       <p:sp>
         <p:nvSpPr>
-          <p:cNvPr id="2" name="Rectangle 1"/>
-          <p:cNvSpPr/>
-          <p:nvPr/>
-        </p:nvSpPr>
-        <p:spPr>
-          <a:xfrm>
-            <a:off x="0" y="2514600"/>
-            <a:ext cx="12191969" cy="1828800"/>
-          </a:xfrm>
-          <a:prstGeom prst="rect">
-            <a:avLst/>
-          </a:prstGeom>
-          <a:solidFill>
-            <a:srgbClr val="241419"/>
-          </a:solidFill>
-          <a:ln>
-            <a:noFill/>
-          </a:ln>
-          <a:effectLst/>
-        </p:spPr>
-        <p:style>
-          <a:lnRef idx="1">
-            <a:schemeClr val="accent1"/>
-          </a:lnRef>
-          <a:fillRef idx="3">
-            <a:schemeClr val="accent1"/>
-          </a:fillRef>
-          <a:effectRef idx="2">
-            <a:schemeClr val="accent1"/>
-          </a:effectRef>
-          <a:fontRef idx="minor">
-            <a:schemeClr val="lt1"/>
-          </a:fontRef>
-        </p:style>
-        <p:txBody>
-          <a:bodyPr rtlCol="0" anchor="ctr"/>
-          <a:lstStyle/>
-          <a:p>
-            <a:pPr algn="ctr"/>
+          <p:cNvPr id="2" name="TextBox 1"/>
+          <p:cNvSpPr txBox="1"/>
+          <p:nvPr/>
+        </p:nvSpPr>
+        <p:spPr>
+          <a:xfrm>
+            <a:off x="777240" y="566928"/>
+            <a:ext cx="10607040" cy="914400"/>
+          </a:xfrm>
+          <a:prstGeom prst="rect">
+            <a:avLst/>
+          </a:prstGeom>
+          <a:noFill/>
+        </p:spPr>
+        <p:txBody>
+          <a:bodyPr wrap="square" anchor="t" lIns="0" rIns="0" tIns="0" bIns="0">
+            <a:spAutoFit/>
+          </a:bodyPr>
+          <a:lstStyle/>
+          <a:p>
+            <a:pPr algn="l">
+              <a:spcAft>
+                <a:spcPts val="0"/>
+              </a:spcAft>
+            </a:pPr>
+            <a:r>
+              <a:rPr sz="3000" b="1">
+                <a:solidFill>
+                  <a:srgbClr val="F2EAEC"/>
+                </a:solidFill>
+                <a:latin typeface="DejaVu Sans"/>
+              </a:rPr>
+              <a:t>An honest status report</a:t>
+            </a:r>
+          </a:p>
+          <a:p>
+            <a:pPr algn="l">
+              <a:spcAft>
+                <a:spcPts val="0"/>
+              </a:spcAft>
+            </a:pPr>
+            <a:r>
+              <a:rPr sz="1400" b="0">
+                <a:solidFill>
+                  <a:srgbClr val="B9A7AE"/>
+                </a:solidFill>
+                <a:latin typeface="DejaVu Sans"/>
+              </a:rPr>
+              <a:t>No unfinished feature is presented as finished</a:t>
+            </a:r>
           </a:p>
         </p:txBody>
       </p:sp>
@@ -32659,8 +32292,8 @@
         </p:nvSpPr>
         <p:spPr>
           <a:xfrm>
-            <a:off x="777240" y="2514600"/>
-            <a:ext cx="63500" cy="1828800"/>
+            <a:off x="777240" y="1572768"/>
+            <a:ext cx="1371600" cy="38100"/>
           </a:xfrm>
           <a:prstGeom prst="rect">
             <a:avLst/>
@@ -32697,92 +32330,666 @@
       </p:sp>
       <p:sp>
         <p:nvSpPr>
-          <p:cNvPr id="4" name="TextBox 3"/>
-          <p:cNvSpPr txBox="1"/>
-          <p:nvPr/>
-        </p:nvSpPr>
-        <p:spPr>
-          <a:xfrm>
-            <a:off x="1188720" y="2834640"/>
-            <a:ext cx="9601200" cy="822960"/>
-          </a:xfrm>
-          <a:prstGeom prst="rect">
-            <a:avLst/>
-          </a:prstGeom>
-          <a:noFill/>
-        </p:spPr>
-        <p:txBody>
-          <a:bodyPr wrap="square" anchor="t" lIns="0" rIns="0" tIns="0" bIns="0">
-            <a:spAutoFit/>
-          </a:bodyPr>
-          <a:lstStyle/>
-          <a:p>
-            <a:pPr algn="l">
-              <a:spcAft>
-                <a:spcPts val="0"/>
-              </a:spcAft>
-            </a:pPr>
-            <a:r>
-              <a:rPr sz="4000" b="1">
+          <p:cNvPr id="4" name="Rounded Rectangle 3"/>
+          <p:cNvSpPr/>
+          <p:nvPr/>
+        </p:nvSpPr>
+        <p:spPr>
+          <a:xfrm>
+            <a:off x="777240" y="1965960"/>
+            <a:ext cx="4919472" cy="3657600"/>
+          </a:xfrm>
+          <a:prstGeom prst="roundRect">
+            <a:avLst>
+              <a:gd name="adj" fmla="val 6000"/>
+            </a:avLst>
+          </a:prstGeom>
+          <a:solidFill>
+            <a:srgbClr val="241419"/>
+          </a:solidFill>
+          <a:ln w="12700">
+            <a:solidFill>
+              <a:srgbClr val="3D2530"/>
+            </a:solidFill>
+          </a:ln>
+          <a:effectLst/>
+        </p:spPr>
+        <p:style>
+          <a:lnRef idx="1">
+            <a:schemeClr val="accent1"/>
+          </a:lnRef>
+          <a:fillRef idx="3">
+            <a:schemeClr val="accent1"/>
+          </a:fillRef>
+          <a:effectRef idx="2">
+            <a:schemeClr val="accent1"/>
+          </a:effectRef>
+          <a:fontRef idx="minor">
+            <a:schemeClr val="lt1"/>
+          </a:fontRef>
+        </p:style>
+        <p:txBody>
+          <a:bodyPr rtlCol="0" anchor="ctr"/>
+          <a:lstStyle/>
+          <a:p>
+            <a:pPr algn="ctr"/>
+          </a:p>
+        </p:txBody>
+      </p:sp>
+      <p:sp>
+        <p:nvSpPr>
+          <p:cNvPr id="5" name="Rectangle 4"/>
+          <p:cNvSpPr/>
+          <p:nvPr/>
+        </p:nvSpPr>
+        <p:spPr>
+          <a:xfrm>
+            <a:off x="777240" y="1965960"/>
+            <a:ext cx="4919472" cy="50800"/>
+          </a:xfrm>
+          <a:prstGeom prst="rect">
+            <a:avLst/>
+          </a:prstGeom>
+          <a:solidFill>
+            <a:srgbClr val="9B4B6B"/>
+          </a:solidFill>
+          <a:ln>
+            <a:noFill/>
+          </a:ln>
+          <a:effectLst/>
+        </p:spPr>
+        <p:style>
+          <a:lnRef idx="1">
+            <a:schemeClr val="accent1"/>
+          </a:lnRef>
+          <a:fillRef idx="3">
+            <a:schemeClr val="accent1"/>
+          </a:fillRef>
+          <a:effectRef idx="2">
+            <a:schemeClr val="accent1"/>
+          </a:effectRef>
+          <a:fontRef idx="minor">
+            <a:schemeClr val="lt1"/>
+          </a:fontRef>
+        </p:style>
+        <p:txBody>
+          <a:bodyPr rtlCol="0" anchor="ctr"/>
+          <a:lstStyle/>
+          <a:p>
+            <a:pPr algn="ctr"/>
+          </a:p>
+        </p:txBody>
+      </p:sp>
+      <p:sp>
+        <p:nvSpPr>
+          <p:cNvPr id="6" name="TextBox 5"/>
+          <p:cNvSpPr txBox="1"/>
+          <p:nvPr/>
+        </p:nvSpPr>
+        <p:spPr>
+          <a:xfrm>
+            <a:off x="1051560" y="2212848"/>
+            <a:ext cx="4389120" cy="457200"/>
+          </a:xfrm>
+          <a:prstGeom prst="rect">
+            <a:avLst/>
+          </a:prstGeom>
+          <a:noFill/>
+        </p:spPr>
+        <p:txBody>
+          <a:bodyPr wrap="square" anchor="t" lIns="0" rIns="0" tIns="0" bIns="0">
+            <a:spAutoFit/>
+          </a:bodyPr>
+          <a:lstStyle/>
+          <a:p>
+            <a:pPr algn="l">
+              <a:spcAft>
+                <a:spcPts val="0"/>
+              </a:spcAft>
+            </a:pPr>
+            <a:r>
+              <a:rPr sz="1500" b="1">
+                <a:solidFill>
+                  <a:srgbClr val="C8A45C"/>
+                </a:solidFill>
+                <a:latin typeface="DejaVu Sans"/>
+              </a:rPr>
+              <a:t>Ready and working</a:t>
+            </a:r>
+          </a:p>
+        </p:txBody>
+      </p:sp>
+      <p:sp>
+        <p:nvSpPr>
+          <p:cNvPr id="7" name="TextBox 6"/>
+          <p:cNvSpPr txBox="1"/>
+          <p:nvPr/>
+        </p:nvSpPr>
+        <p:spPr>
+          <a:xfrm>
+            <a:off x="1051560" y="2761488"/>
+            <a:ext cx="4434840" cy="566928"/>
+          </a:xfrm>
+          <a:prstGeom prst="rect">
+            <a:avLst/>
+          </a:prstGeom>
+          <a:noFill/>
+        </p:spPr>
+        <p:txBody>
+          <a:bodyPr wrap="square" anchor="t" lIns="0" rIns="0" tIns="0" bIns="0">
+            <a:spAutoFit/>
+          </a:bodyPr>
+          <a:lstStyle/>
+          <a:p>
+            <a:pPr algn="l">
+              <a:spcAft>
+                <a:spcPts val="0"/>
+              </a:spcAft>
+            </a:pPr>
+            <a:r>
+              <a:rPr sz="1250" b="0">
                 <a:solidFill>
                   <a:srgbClr val="F2EAEC"/>
                 </a:solidFill>
                 <a:latin typeface="DejaVu Sans"/>
               </a:rPr>
-              <a:t>Screens from the Application</a:t>
-            </a:r>
-          </a:p>
-        </p:txBody>
-      </p:sp>
-      <p:sp>
-        <p:nvSpPr>
-          <p:cNvPr id="5" name="TextBox 4"/>
-          <p:cNvSpPr txBox="1"/>
-          <p:nvPr/>
-        </p:nvSpPr>
-        <p:spPr>
-          <a:xfrm>
-            <a:off x="1188720" y="3611880"/>
-            <a:ext cx="9601200" cy="548640"/>
-          </a:xfrm>
-          <a:prstGeom prst="rect">
-            <a:avLst/>
-          </a:prstGeom>
-          <a:noFill/>
-        </p:spPr>
-        <p:txBody>
-          <a:bodyPr wrap="square" anchor="t" lIns="0" rIns="0" tIns="0" bIns="0">
-            <a:spAutoFit/>
-          </a:bodyPr>
-          <a:lstStyle/>
-          <a:p>
-            <a:pPr algn="l">
-              <a:spcAft>
-                <a:spcPts val="0"/>
-              </a:spcAft>
-            </a:pPr>
-            <a:r>
-              <a:rPr sz="1600" b="0">
+              <a:t>·  Floor operations · KDS · payment · day close</a:t>
+            </a:r>
+          </a:p>
+        </p:txBody>
+      </p:sp>
+      <p:sp>
+        <p:nvSpPr>
+          <p:cNvPr id="8" name="TextBox 7"/>
+          <p:cNvSpPr txBox="1"/>
+          <p:nvPr/>
+        </p:nvSpPr>
+        <p:spPr>
+          <a:xfrm>
+            <a:off x="1051560" y="3328416"/>
+            <a:ext cx="4434840" cy="566928"/>
+          </a:xfrm>
+          <a:prstGeom prst="rect">
+            <a:avLst/>
+          </a:prstGeom>
+          <a:noFill/>
+        </p:spPr>
+        <p:txBody>
+          <a:bodyPr wrap="square" anchor="t" lIns="0" rIns="0" tIns="0" bIns="0">
+            <a:spAutoFit/>
+          </a:bodyPr>
+          <a:lstStyle/>
+          <a:p>
+            <a:pPr algn="l">
+              <a:spcAft>
+                <a:spcPts val="0"/>
+              </a:spcAft>
+            </a:pPr>
+            <a:r>
+              <a:rPr sz="1250" b="0">
+                <a:solidFill>
+                  <a:srgbClr val="F2EAEC"/>
+                </a:solidFill>
+                <a:latin typeface="DejaVu Sans"/>
+              </a:rPr>
+              <a:t>·  Wine cellar · by-the-glass service · yield analysis</a:t>
+            </a:r>
+          </a:p>
+        </p:txBody>
+      </p:sp>
+      <p:sp>
+        <p:nvSpPr>
+          <p:cNvPr id="9" name="TextBox 8"/>
+          <p:cNvSpPr txBox="1"/>
+          <p:nvPr/>
+        </p:nvSpPr>
+        <p:spPr>
+          <a:xfrm>
+            <a:off x="1051560" y="3895344"/>
+            <a:ext cx="4434840" cy="566928"/>
+          </a:xfrm>
+          <a:prstGeom prst="rect">
+            <a:avLst/>
+          </a:prstGeom>
+          <a:noFill/>
+        </p:spPr>
+        <p:txBody>
+          <a:bodyPr wrap="square" anchor="t" lIns="0" rIns="0" tIns="0" bIns="0">
+            <a:spAutoFit/>
+          </a:bodyPr>
+          <a:lstStyle/>
+          <a:p>
+            <a:pPr algn="l">
+              <a:spcAft>
+                <a:spcPts val="0"/>
+              </a:spcAft>
+            </a:pPr>
+            <a:r>
+              <a:rPr sz="1250" b="0">
+                <a:solidFill>
+                  <a:srgbClr val="F2EAEC"/>
+                </a:solidFill>
+                <a:latin typeface="DejaVu Sans"/>
+              </a:rPr>
+              <a:t>·  Inventory · purchasing · waste · stock counts</a:t>
+            </a:r>
+          </a:p>
+        </p:txBody>
+      </p:sp>
+      <p:sp>
+        <p:nvSpPr>
+          <p:cNvPr id="10" name="TextBox 9"/>
+          <p:cNvSpPr txBox="1"/>
+          <p:nvPr/>
+        </p:nvSpPr>
+        <p:spPr>
+          <a:xfrm>
+            <a:off x="1051560" y="4462272"/>
+            <a:ext cx="4434840" cy="566928"/>
+          </a:xfrm>
+          <a:prstGeom prst="rect">
+            <a:avLst/>
+          </a:prstGeom>
+          <a:noFill/>
+        </p:spPr>
+        <p:txBody>
+          <a:bodyPr wrap="square" anchor="t" lIns="0" rIns="0" tIns="0" bIns="0">
+            <a:spAutoFit/>
+          </a:bodyPr>
+          <a:lstStyle/>
+          <a:p>
+            <a:pPr algn="l">
+              <a:spcAft>
+                <a:spcPts val="0"/>
+              </a:spcAft>
+            </a:pPr>
+            <a:r>
+              <a:rPr sz="1250" b="0">
+                <a:solidFill>
+                  <a:srgbClr val="F2EAEC"/>
+                </a:solidFill>
+                <a:latin typeface="DejaVu Sans"/>
+              </a:rPr>
+              <a:t>·  CRM · GDPR · staff · 13 reports</a:t>
+            </a:r>
+          </a:p>
+        </p:txBody>
+      </p:sp>
+      <p:sp>
+        <p:nvSpPr>
+          <p:cNvPr id="11" name="TextBox 10"/>
+          <p:cNvSpPr txBox="1"/>
+          <p:nvPr/>
+        </p:nvSpPr>
+        <p:spPr>
+          <a:xfrm>
+            <a:off x="1051560" y="5029200"/>
+            <a:ext cx="4434840" cy="566928"/>
+          </a:xfrm>
+          <a:prstGeom prst="rect">
+            <a:avLst/>
+          </a:prstGeom>
+          <a:noFill/>
+        </p:spPr>
+        <p:txBody>
+          <a:bodyPr wrap="square" anchor="t" lIns="0" rIns="0" tIns="0" bIns="0">
+            <a:spAutoFit/>
+          </a:bodyPr>
+          <a:lstStyle/>
+          <a:p>
+            <a:pPr algn="l">
+              <a:spcAft>
+                <a:spcPts val="0"/>
+              </a:spcAft>
+            </a:pPr>
+            <a:r>
+              <a:rPr sz="1250" b="0">
+                <a:solidFill>
+                  <a:srgbClr val="F2EAEC"/>
+                </a:solidFill>
+                <a:latin typeface="DejaVu Sans"/>
+              </a:rPr>
+              <a:t>·  AI layer · backups · 19 roles</a:t>
+            </a:r>
+          </a:p>
+        </p:txBody>
+      </p:sp>
+      <p:sp>
+        <p:nvSpPr>
+          <p:cNvPr id="12" name="Rounded Rectangle 11"/>
+          <p:cNvSpPr/>
+          <p:nvPr/>
+        </p:nvSpPr>
+        <p:spPr>
+          <a:xfrm>
+            <a:off x="6492240" y="1965960"/>
+            <a:ext cx="4919472" cy="3657600"/>
+          </a:xfrm>
+          <a:prstGeom prst="roundRect">
+            <a:avLst>
+              <a:gd name="adj" fmla="val 6000"/>
+            </a:avLst>
+          </a:prstGeom>
+          <a:solidFill>
+            <a:srgbClr val="241419"/>
+          </a:solidFill>
+          <a:ln w="12700">
+            <a:solidFill>
+              <a:srgbClr val="3D2530"/>
+            </a:solidFill>
+          </a:ln>
+          <a:effectLst/>
+        </p:spPr>
+        <p:style>
+          <a:lnRef idx="1">
+            <a:schemeClr val="accent1"/>
+          </a:lnRef>
+          <a:fillRef idx="3">
+            <a:schemeClr val="accent1"/>
+          </a:fillRef>
+          <a:effectRef idx="2">
+            <a:schemeClr val="accent1"/>
+          </a:effectRef>
+          <a:fontRef idx="minor">
+            <a:schemeClr val="lt1"/>
+          </a:fontRef>
+        </p:style>
+        <p:txBody>
+          <a:bodyPr rtlCol="0" anchor="ctr"/>
+          <a:lstStyle/>
+          <a:p>
+            <a:pPr algn="ctr"/>
+          </a:p>
+        </p:txBody>
+      </p:sp>
+      <p:sp>
+        <p:nvSpPr>
+          <p:cNvPr id="13" name="Rectangle 12"/>
+          <p:cNvSpPr/>
+          <p:nvPr/>
+        </p:nvSpPr>
+        <p:spPr>
+          <a:xfrm>
+            <a:off x="6492240" y="1965960"/>
+            <a:ext cx="4919472" cy="50800"/>
+          </a:xfrm>
+          <a:prstGeom prst="rect">
+            <a:avLst/>
+          </a:prstGeom>
+          <a:solidFill>
+            <a:srgbClr val="C8A45C"/>
+          </a:solidFill>
+          <a:ln>
+            <a:noFill/>
+          </a:ln>
+          <a:effectLst/>
+        </p:spPr>
+        <p:style>
+          <a:lnRef idx="1">
+            <a:schemeClr val="accent1"/>
+          </a:lnRef>
+          <a:fillRef idx="3">
+            <a:schemeClr val="accent1"/>
+          </a:fillRef>
+          <a:effectRef idx="2">
+            <a:schemeClr val="accent1"/>
+          </a:effectRef>
+          <a:fontRef idx="minor">
+            <a:schemeClr val="lt1"/>
+          </a:fontRef>
+        </p:style>
+        <p:txBody>
+          <a:bodyPr rtlCol="0" anchor="ctr"/>
+          <a:lstStyle/>
+          <a:p>
+            <a:pPr algn="ctr"/>
+          </a:p>
+        </p:txBody>
+      </p:sp>
+      <p:sp>
+        <p:nvSpPr>
+          <p:cNvPr id="14" name="TextBox 13"/>
+          <p:cNvSpPr txBox="1"/>
+          <p:nvPr/>
+        </p:nvSpPr>
+        <p:spPr>
+          <a:xfrm>
+            <a:off x="6766559" y="2212848"/>
+            <a:ext cx="4389120" cy="457200"/>
+          </a:xfrm>
+          <a:prstGeom prst="rect">
+            <a:avLst/>
+          </a:prstGeom>
+          <a:noFill/>
+        </p:spPr>
+        <p:txBody>
+          <a:bodyPr wrap="square" anchor="t" lIns="0" rIns="0" tIns="0" bIns="0">
+            <a:spAutoFit/>
+          </a:bodyPr>
+          <a:lstStyle/>
+          <a:p>
+            <a:pPr algn="l">
+              <a:spcAft>
+                <a:spcPts val="0"/>
+              </a:spcAft>
+            </a:pPr>
+            <a:r>
+              <a:rPr sz="1500" b="1">
                 <a:solidFill>
                   <a:srgbClr val="C8A45C"/>
                 </a:solidFill>
                 <a:latin typeface="DejaVu Sans"/>
               </a:rPr>
-              <a:t>Real interface · synthetic demo data · v0.1.0 · UI shown in Turkish (EN toggle built in)</a:t>
-            </a:r>
-          </a:p>
-        </p:txBody>
-      </p:sp>
-      <p:sp>
-        <p:nvSpPr>
-          <p:cNvPr id="6" name="TextBox 5"/>
-          <p:cNvSpPr txBox="1"/>
-          <p:nvPr/>
-        </p:nvSpPr>
-        <p:spPr>
-          <a:xfrm>
-            <a:off x="777240" y="1463040"/>
-            <a:ext cx="3657600" cy="365760"/>
+              <a:t>Experimental or planned</a:t>
+            </a:r>
+          </a:p>
+        </p:txBody>
+      </p:sp>
+      <p:sp>
+        <p:nvSpPr>
+          <p:cNvPr id="15" name="TextBox 14"/>
+          <p:cNvSpPr txBox="1"/>
+          <p:nvPr/>
+        </p:nvSpPr>
+        <p:spPr>
+          <a:xfrm>
+            <a:off x="6766559" y="2761488"/>
+            <a:ext cx="4434840" cy="566928"/>
+          </a:xfrm>
+          <a:prstGeom prst="rect">
+            <a:avLst/>
+          </a:prstGeom>
+          <a:noFill/>
+        </p:spPr>
+        <p:txBody>
+          <a:bodyPr wrap="square" anchor="t" lIns="0" rIns="0" tIns="0" bIns="0">
+            <a:spAutoFit/>
+          </a:bodyPr>
+          <a:lstStyle/>
+          <a:p>
+            <a:pPr algn="l">
+              <a:spcAft>
+                <a:spcPts val="0"/>
+              </a:spcAft>
+            </a:pPr>
+            <a:r>
+              <a:rPr sz="1250" b="0">
+                <a:solidFill>
+                  <a:srgbClr val="F2EAEC"/>
+                </a:solidFill>
+                <a:latin typeface="DejaVu Sans"/>
+              </a:rPr>
+              <a:t>·  Live payment and e-invoicing (adapter only)</a:t>
+            </a:r>
+          </a:p>
+        </p:txBody>
+      </p:sp>
+      <p:sp>
+        <p:nvSpPr>
+          <p:cNvPr id="16" name="TextBox 15"/>
+          <p:cNvSpPr txBox="1"/>
+          <p:nvPr/>
+        </p:nvSpPr>
+        <p:spPr>
+          <a:xfrm>
+            <a:off x="6766559" y="3328416"/>
+            <a:ext cx="4434840" cy="566928"/>
+          </a:xfrm>
+          <a:prstGeom prst="rect">
+            <a:avLst/>
+          </a:prstGeom>
+          <a:noFill/>
+        </p:spPr>
+        <p:txBody>
+          <a:bodyPr wrap="square" anchor="t" lIns="0" rIns="0" tIns="0" bIns="0">
+            <a:spAutoFit/>
+          </a:bodyPr>
+          <a:lstStyle/>
+          <a:p>
+            <a:pPr algn="l">
+              <a:spcAft>
+                <a:spcPts val="0"/>
+              </a:spcAft>
+            </a:pPr>
+            <a:r>
+              <a:rPr sz="1250" b="0">
+                <a:solidFill>
+                  <a:srgbClr val="F2EAEC"/>
+                </a:solidFill>
+                <a:latin typeface="DejaVu Sans"/>
+              </a:rPr>
+              <a:t>·  Thermal printer driver</a:t>
+            </a:r>
+          </a:p>
+        </p:txBody>
+      </p:sp>
+      <p:sp>
+        <p:nvSpPr>
+          <p:cNvPr id="17" name="TextBox 16"/>
+          <p:cNvSpPr txBox="1"/>
+          <p:nvPr/>
+        </p:nvSpPr>
+        <p:spPr>
+          <a:xfrm>
+            <a:off x="6766559" y="3895344"/>
+            <a:ext cx="4434840" cy="566928"/>
+          </a:xfrm>
+          <a:prstGeom prst="rect">
+            <a:avLst/>
+          </a:prstGeom>
+          <a:noFill/>
+        </p:spPr>
+        <p:txBody>
+          <a:bodyPr wrap="square" anchor="t" lIns="0" rIns="0" tIns="0" bIns="0">
+            <a:spAutoFit/>
+          </a:bodyPr>
+          <a:lstStyle/>
+          <a:p>
+            <a:pPr algn="l">
+              <a:spcAft>
+                <a:spcPts val="0"/>
+              </a:spcAft>
+            </a:pPr>
+            <a:r>
+              <a:rPr sz="1250" b="0">
+                <a:solidFill>
+                  <a:srgbClr val="F2EAEC"/>
+                </a:solidFill>
+                <a:latin typeface="DejaVu Sans"/>
+              </a:rPr>
+              <a:t>·  Bulk email/SMS dispatch</a:t>
+            </a:r>
+          </a:p>
+        </p:txBody>
+      </p:sp>
+      <p:sp>
+        <p:nvSpPr>
+          <p:cNvPr id="18" name="TextBox 17"/>
+          <p:cNvSpPr txBox="1"/>
+          <p:nvPr/>
+        </p:nvSpPr>
+        <p:spPr>
+          <a:xfrm>
+            <a:off x="6766559" y="4462272"/>
+            <a:ext cx="4434840" cy="566928"/>
+          </a:xfrm>
+          <a:prstGeom prst="rect">
+            <a:avLst/>
+          </a:prstGeom>
+          <a:noFill/>
+        </p:spPr>
+        <p:txBody>
+          <a:bodyPr wrap="square" anchor="t" lIns="0" rIns="0" tIns="0" bIns="0">
+            <a:spAutoFit/>
+          </a:bodyPr>
+          <a:lstStyle/>
+          <a:p>
+            <a:pPr algn="l">
+              <a:spcAft>
+                <a:spcPts val="0"/>
+              </a:spcAft>
+            </a:pPr>
+            <a:r>
+              <a:rPr sz="1250" b="0">
+                <a:solidFill>
+                  <a:srgbClr val="F2EAEC"/>
+                </a:solidFill>
+                <a:latin typeface="DejaVu Sans"/>
+              </a:rPr>
+              <a:t>·  Cellar sensor integration</a:t>
+            </a:r>
+          </a:p>
+        </p:txBody>
+      </p:sp>
+      <p:sp>
+        <p:nvSpPr>
+          <p:cNvPr id="19" name="TextBox 18"/>
+          <p:cNvSpPr txBox="1"/>
+          <p:nvPr/>
+        </p:nvSpPr>
+        <p:spPr>
+          <a:xfrm>
+            <a:off x="6766559" y="5029200"/>
+            <a:ext cx="4434840" cy="566928"/>
+          </a:xfrm>
+          <a:prstGeom prst="rect">
+            <a:avLst/>
+          </a:prstGeom>
+          <a:noFill/>
+        </p:spPr>
+        <p:txBody>
+          <a:bodyPr wrap="square" anchor="t" lIns="0" rIns="0" tIns="0" bIns="0">
+            <a:spAutoFit/>
+          </a:bodyPr>
+          <a:lstStyle/>
+          <a:p>
+            <a:pPr algn="l">
+              <a:spcAft>
+                <a:spcPts val="0"/>
+              </a:spcAft>
+            </a:pPr>
+            <a:r>
+              <a:rPr sz="1250" b="0">
+                <a:solidFill>
+                  <a:srgbClr val="F2EAEC"/>
+                </a:solidFill>
+                <a:latin typeface="DejaVu Sans"/>
+              </a:rPr>
+              <a:t>·  Label image analysis · multi-terminal sync</a:t>
+            </a:r>
+          </a:p>
+        </p:txBody>
+      </p:sp>
+      <p:sp>
+        <p:nvSpPr>
+          <p:cNvPr id="20" name="TextBox 19"/>
+          <p:cNvSpPr txBox="1"/>
+          <p:nvPr/>
+        </p:nvSpPr>
+        <p:spPr>
+          <a:xfrm>
+            <a:off x="777240" y="5779008"/>
+            <a:ext cx="10607040" cy="457200"/>
           </a:xfrm>
           <a:prstGeom prst="rect">
             <a:avLst/>
@@ -32807,14 +33014,14 @@
                 </a:solidFill>
                 <a:latin typeface="DejaVu Sans"/>
               </a:rPr>
-              <a:t>42 / 57</a:t>
-            </a:r>
-          </a:p>
-        </p:txBody>
-      </p:sp>
-      <p:sp>
-        <p:nvSpPr>
-          <p:cNvPr id="7" name="TextBox 6"/>
+              <a:t>Every feature carries a badge in the application: Ready · Experimental · Planned</a:t>
+            </a:r>
+          </a:p>
+        </p:txBody>
+      </p:sp>
+      <p:sp>
+        <p:nvSpPr>
+          <p:cNvPr id="21" name="TextBox 20"/>
           <p:cNvSpPr txBox="1"/>
           <p:nvPr/>
         </p:nvSpPr>
@@ -32853,7 +33060,7 @@
       </p:sp>
       <p:sp>
         <p:nvSpPr>
-          <p:cNvPr id="8" name="TextBox 7"/>
+          <p:cNvPr id="22" name="TextBox 21"/>
           <p:cNvSpPr txBox="1"/>
           <p:nvPr/>
         </p:nvSpPr>
@@ -32918,40 +33125,45 @@
       <p:grpSpPr/>
       <p:sp>
         <p:nvSpPr>
-          <p:cNvPr id="2" name="TextBox 1"/>
-          <p:cNvSpPr txBox="1"/>
-          <p:nvPr/>
-        </p:nvSpPr>
-        <p:spPr>
-          <a:xfrm>
-            <a:off x="777240" y="566928"/>
-            <a:ext cx="10607040" cy="914400"/>
-          </a:xfrm>
-          <a:prstGeom prst="rect">
-            <a:avLst/>
-          </a:prstGeom>
-          <a:noFill/>
-        </p:spPr>
-        <p:txBody>
-          <a:bodyPr wrap="square" anchor="t" lIns="0" rIns="0" tIns="0" bIns="0">
-            <a:spAutoFit/>
-          </a:bodyPr>
-          <a:lstStyle/>
-          <a:p>
-            <a:pPr algn="l">
-              <a:spcAft>
-                <a:spcPts val="0"/>
-              </a:spcAft>
-            </a:pPr>
-            <a:r>
-              <a:rPr sz="3000" b="1">
-                <a:solidFill>
-                  <a:srgbClr val="F2EAEC"/>
-                </a:solidFill>
-                <a:latin typeface="DejaVu Sans"/>
-              </a:rPr>
-              <a:t>Sign-in screen</a:t>
-            </a:r>
+          <p:cNvPr id="2" name="Rectangle 1"/>
+          <p:cNvSpPr/>
+          <p:nvPr/>
+        </p:nvSpPr>
+        <p:spPr>
+          <a:xfrm>
+            <a:off x="0" y="2514600"/>
+            <a:ext cx="12191969" cy="1828800"/>
+          </a:xfrm>
+          <a:prstGeom prst="rect">
+            <a:avLst/>
+          </a:prstGeom>
+          <a:solidFill>
+            <a:srgbClr val="241419"/>
+          </a:solidFill>
+          <a:ln>
+            <a:noFill/>
+          </a:ln>
+          <a:effectLst/>
+        </p:spPr>
+        <p:style>
+          <a:lnRef idx="1">
+            <a:schemeClr val="accent1"/>
+          </a:lnRef>
+          <a:fillRef idx="3">
+            <a:schemeClr val="accent1"/>
+          </a:fillRef>
+          <a:effectRef idx="2">
+            <a:schemeClr val="accent1"/>
+          </a:effectRef>
+          <a:fontRef idx="minor">
+            <a:schemeClr val="lt1"/>
+          </a:fontRef>
+        </p:style>
+        <p:txBody>
+          <a:bodyPr rtlCol="0" anchor="ctr"/>
+          <a:lstStyle/>
+          <a:p>
+            <a:pPr algn="ctr"/>
           </a:p>
         </p:txBody>
       </p:sp>
@@ -32963,8 +33175,8 @@
         </p:nvSpPr>
         <p:spPr>
           <a:xfrm>
-            <a:off x="777240" y="1572768"/>
-            <a:ext cx="1371600" cy="38100"/>
+            <a:off x="777240" y="2514600"/>
+            <a:ext cx="63500" cy="1828800"/>
           </a:xfrm>
           <a:prstGeom prst="rect">
             <a:avLst/>
@@ -33001,76 +33213,82 @@
       </p:sp>
       <p:sp>
         <p:nvSpPr>
-          <p:cNvPr id="4" name="Rounded Rectangle 3"/>
-          <p:cNvSpPr/>
-          <p:nvPr/>
-        </p:nvSpPr>
-        <p:spPr>
-          <a:xfrm>
-            <a:off x="2815437" y="1801368"/>
-            <a:ext cx="6558076" cy="4133087"/>
-          </a:xfrm>
-          <a:prstGeom prst="roundRect">
-            <a:avLst>
-              <a:gd name="adj" fmla="val 6000"/>
-            </a:avLst>
-          </a:prstGeom>
-          <a:solidFill>
-            <a:srgbClr val="241419"/>
-          </a:solidFill>
-          <a:ln w="12700">
-            <a:solidFill>
-              <a:srgbClr val="3D2530"/>
-            </a:solidFill>
-          </a:ln>
-          <a:effectLst/>
-        </p:spPr>
-        <p:style>
-          <a:lnRef idx="1">
-            <a:schemeClr val="accent1"/>
-          </a:lnRef>
-          <a:fillRef idx="3">
-            <a:schemeClr val="accent1"/>
-          </a:fillRef>
-          <a:effectRef idx="2">
-            <a:schemeClr val="accent1"/>
-          </a:effectRef>
-          <a:fontRef idx="minor">
-            <a:schemeClr val="lt1"/>
-          </a:fontRef>
-        </p:style>
-        <p:txBody>
-          <a:bodyPr rtlCol="0" anchor="ctr"/>
-          <a:lstStyle/>
-          <a:p>
-            <a:pPr algn="ctr"/>
-          </a:p>
-        </p:txBody>
-      </p:sp>
-      <p:pic>
-        <p:nvPicPr>
-          <p:cNvPr id="5" name="Picture 4" descr="login.png"/>
-          <p:cNvPicPr>
-            <a:picLocks noChangeAspect="1"/>
-          </p:cNvPicPr>
-          <p:nvPr/>
-        </p:nvPicPr>
-        <p:blipFill>
-          <a:blip r:embed="rId2"/>
-          <a:stretch>
-            <a:fillRect/>
-          </a:stretch>
-        </p:blipFill>
-        <p:spPr>
-          <a:xfrm>
-            <a:off x="2861157" y="1847088"/>
-            <a:ext cx="6466636" cy="4041648"/>
-          </a:xfrm>
-          <a:prstGeom prst="rect">
-            <a:avLst/>
-          </a:prstGeom>
-        </p:spPr>
-      </p:pic>
+          <p:cNvPr id="4" name="TextBox 3"/>
+          <p:cNvSpPr txBox="1"/>
+          <p:nvPr/>
+        </p:nvSpPr>
+        <p:spPr>
+          <a:xfrm>
+            <a:off x="1188720" y="2834640"/>
+            <a:ext cx="9601200" cy="822960"/>
+          </a:xfrm>
+          <a:prstGeom prst="rect">
+            <a:avLst/>
+          </a:prstGeom>
+          <a:noFill/>
+        </p:spPr>
+        <p:txBody>
+          <a:bodyPr wrap="square" anchor="t" lIns="0" rIns="0" tIns="0" bIns="0">
+            <a:spAutoFit/>
+          </a:bodyPr>
+          <a:lstStyle/>
+          <a:p>
+            <a:pPr algn="l">
+              <a:spcAft>
+                <a:spcPts val="0"/>
+              </a:spcAft>
+            </a:pPr>
+            <a:r>
+              <a:rPr sz="4000" b="1">
+                <a:solidFill>
+                  <a:srgbClr val="F2EAEC"/>
+                </a:solidFill>
+                <a:latin typeface="DejaVu Sans"/>
+              </a:rPr>
+              <a:t>Screens from the Application</a:t>
+            </a:r>
+          </a:p>
+        </p:txBody>
+      </p:sp>
+      <p:sp>
+        <p:nvSpPr>
+          <p:cNvPr id="5" name="TextBox 4"/>
+          <p:cNvSpPr txBox="1"/>
+          <p:nvPr/>
+        </p:nvSpPr>
+        <p:spPr>
+          <a:xfrm>
+            <a:off x="1188720" y="3611880"/>
+            <a:ext cx="9601200" cy="548640"/>
+          </a:xfrm>
+          <a:prstGeom prst="rect">
+            <a:avLst/>
+          </a:prstGeom>
+          <a:noFill/>
+        </p:spPr>
+        <p:txBody>
+          <a:bodyPr wrap="square" anchor="t" lIns="0" rIns="0" tIns="0" bIns="0">
+            <a:spAutoFit/>
+          </a:bodyPr>
+          <a:lstStyle/>
+          <a:p>
+            <a:pPr algn="l">
+              <a:spcAft>
+                <a:spcPts val="0"/>
+              </a:spcAft>
+            </a:pPr>
+            <a:r>
+              <a:rPr sz="1600" b="0">
+                <a:solidFill>
+                  <a:srgbClr val="C8A45C"/>
+                </a:solidFill>
+                <a:latin typeface="DejaVu Sans"/>
+              </a:rPr>
+              <a:t>Real interface · synthetic demo data · v0.1.0 · UI shown in Turkish (EN toggle built in)</a:t>
+            </a:r>
+          </a:p>
+        </p:txBody>
+      </p:sp>
       <p:sp>
         <p:nvSpPr>
           <p:cNvPr id="6" name="TextBox 5"/>
@@ -33079,33 +33297,33 @@
         </p:nvSpPr>
         <p:spPr>
           <a:xfrm>
-            <a:off x="777240" y="6016751"/>
-            <a:ext cx="10607040" cy="457200"/>
-          </a:xfrm>
-          <a:prstGeom prst="rect">
-            <a:avLst/>
-          </a:prstGeom>
-          <a:noFill/>
-        </p:spPr>
-        <p:txBody>
-          <a:bodyPr wrap="square" anchor="t" lIns="0" rIns="0" tIns="0" bIns="0">
-            <a:spAutoFit/>
-          </a:bodyPr>
-          <a:lstStyle/>
-          <a:p>
-            <a:pPr algn="l">
-              <a:spcAft>
-                <a:spcPts val="0"/>
-              </a:spcAft>
-            </a:pPr>
-            <a:r>
-              <a:rPr sz="1150" b="0">
+            <a:off x="777240" y="1463040"/>
+            <a:ext cx="3657600" cy="365760"/>
+          </a:xfrm>
+          <a:prstGeom prst="rect">
+            <a:avLst/>
+          </a:prstGeom>
+          <a:noFill/>
+        </p:spPr>
+        <p:txBody>
+          <a:bodyPr wrap="square" anchor="t" lIns="0" rIns="0" tIns="0" bIns="0">
+            <a:spAutoFit/>
+          </a:bodyPr>
+          <a:lstStyle/>
+          <a:p>
+            <a:pPr algn="l">
+              <a:spcAft>
+                <a:spcPts val="0"/>
+              </a:spcAft>
+            </a:pPr>
+            <a:r>
+              <a:rPr sz="1100" b="0">
                 <a:solidFill>
                   <a:srgbClr val="B9A7AE"/>
                 </a:solidFill>
                 <a:latin typeface="DejaVu Sans"/>
               </a:rPr>
-              <a:t>Password or quick PIN sign-in · role-based access starts with 19 roles</a:t>
+              <a:t>43 / 58</a:t>
             </a:r>
           </a:p>
         </p:txBody>
@@ -33248,7 +33466,7 @@
                 </a:solidFill>
                 <a:latin typeface="DejaVu Sans"/>
               </a:rPr>
-              <a:t>Main dashboard</a:t>
+              <a:t>Sign-in screen</a:t>
             </a:r>
           </a:p>
         </p:txBody>
@@ -33347,7 +33565,7 @@
       </p:sp>
       <p:pic>
         <p:nvPicPr>
-          <p:cNvPr id="5" name="Picture 4" descr="dashboard.png"/>
+          <p:cNvPr id="5" name="Picture 4" descr="login.png"/>
           <p:cNvPicPr>
             <a:picLocks noChangeAspect="1"/>
           </p:cNvPicPr>
@@ -33403,7 +33621,7 @@
                 </a:solidFill>
                 <a:latin typeface="DejaVu Sans"/>
               </a:rPr>
-              <a:t>Tables, open orders, reservations, cellar and sales at a glance; experimental features are clearly badged</a:t>
+              <a:t>Password or quick PIN sign-in · role-based access starts with 19 roles</a:t>
             </a:r>
           </a:p>
         </p:txBody>
@@ -33546,7 +33764,7 @@
                 </a:solidFill>
                 <a:latin typeface="DejaVu Sans"/>
               </a:rPr>
-              <a:t>Table map</a:t>
+              <a:t>Main dashboard</a:t>
             </a:r>
           </a:p>
         </p:txBody>
@@ -33645,7 +33863,7 @@
       </p:sp>
       <p:pic>
         <p:nvPicPr>
-          <p:cNvPr id="5" name="Picture 4" descr="masa-plani.png"/>
+          <p:cNvPr id="5" name="Picture 4" descr="dashboard.png"/>
           <p:cNvPicPr>
             <a:picLocks noChangeAspect="1"/>
           </p:cNvPicPr>
@@ -33701,7 +33919,7 @@
                 </a:solidFill>
                 <a:latin typeface="DejaVu Sans"/>
               </a:rPr>
-              <a:t>Live table status by section with links to open orders</a:t>
+              <a:t>Tables, open orders, reservations, cellar and sales at a glance; experimental features are clearly badged</a:t>
             </a:r>
           </a:p>
         </p:txBody>
@@ -33844,7 +34062,7 @@
                 </a:solidFill>
                 <a:latin typeface="DejaVu Sans"/>
               </a:rPr>
-              <a:t>Orders</a:t>
+              <a:t>Table map</a:t>
             </a:r>
           </a:p>
         </p:txBody>
@@ -33943,7 +34161,7 @@
       </p:sp>
       <p:pic>
         <p:nvPicPr>
-          <p:cNvPr id="5" name="Picture 4" descr="adisyonlar.png"/>
+          <p:cNvPr id="5" name="Picture 4" descr="masa-plani.png"/>
           <p:cNvPicPr>
             <a:picLocks noChangeAspect="1"/>
           </p:cNvPicPr>
@@ -33999,7 +34217,7 @@
                 </a:solidFill>
                 <a:latin typeface="DejaVu Sans"/>
               </a:rPr>
-              <a:t>Order management with price freezing, line voids, discounts and approvals</a:t>
+              <a:t>Live table status by section with links to open orders</a:t>
             </a:r>
           </a:p>
         </p:txBody>
@@ -34142,7 +34360,7 @@
                 </a:solidFill>
                 <a:latin typeface="DejaVu Sans"/>
               </a:rPr>
-              <a:t>Reservations</a:t>
+              <a:t>Orders</a:t>
             </a:r>
           </a:p>
         </p:txBody>
@@ -34241,7 +34459,7 @@
       </p:sp>
       <p:pic>
         <p:nvPicPr>
-          <p:cNvPr id="5" name="Picture 4" descr="rezervasyonlar.png"/>
+          <p:cNvPr id="5" name="Picture 4" descr="adisyonlar.png"/>
           <p:cNvPicPr>
             <a:picLocks noChangeAspect="1"/>
           </p:cNvPicPr>
@@ -34297,7 +34515,7 @@
                 </a:solidFill>
                 <a:latin typeface="DejaVu Sans"/>
               </a:rPr>
-              <a:t>Conflict checking, capacity control and waitlist</a:t>
+              <a:t>Order management with price freezing, line voids, discounts and approvals</a:t>
             </a:r>
           </a:p>
         </p:txBody>
@@ -34440,7 +34658,7 @@
                 </a:solidFill>
                 <a:latin typeface="DejaVu Sans"/>
               </a:rPr>
-              <a:t>Kitchen display (KDS)</a:t>
+              <a:t>Reservations</a:t>
             </a:r>
           </a:p>
         </p:txBody>
@@ -34539,7 +34757,7 @@
       </p:sp>
       <p:pic>
         <p:nvPicPr>
-          <p:cNvPr id="5" name="Picture 4" descr="kds-mutfak.png"/>
+          <p:cNvPr id="5" name="Picture 4" descr="rezervasyonlar.png"/>
           <p:cNvPicPr>
             <a:picLocks noChangeAspect="1"/>
           </p:cNvPicPr>
@@ -34595,7 +34813,7 @@
                 </a:solidFill>
                 <a:latin typeface="DejaVu Sans"/>
               </a:rPr>
-              <a:t>Station separation, ticket progression, delay warnings and allergen flags</a:t>
+              <a:t>Conflict checking, capacity control and waitlist</a:t>
             </a:r>
           </a:p>
         </p:txBody>
@@ -34738,7 +34956,7 @@
                 </a:solidFill>
                 <a:latin typeface="DejaVu Sans"/>
               </a:rPr>
-              <a:t>Wine cellar</a:t>
+              <a:t>Kitchen display (KDS)</a:t>
             </a:r>
           </a:p>
         </p:txBody>
@@ -34837,7 +35055,7 @@
       </p:sp>
       <p:pic>
         <p:nvPicPr>
-          <p:cNvPr id="5" name="Picture 4" descr="sarap-kavi.png"/>
+          <p:cNvPr id="5" name="Picture 4" descr="kds-mutfak.png"/>
           <p:cNvPicPr>
             <a:picLocks noChangeAspect="1"/>
           </p:cNvPicPr>
@@ -34893,7 +35111,7 @@
                 </a:solidFill>
                 <a:latin typeface="DejaVu Sans"/>
               </a:rPr>
-              <a:t>Bottle and by-the-glass stock, drinking windows and pricing</a:t>
+              <a:t>Station separation, ticket progression, delay warnings and allergen flags</a:t>
             </a:r>
           </a:p>
         </p:txBody>
@@ -36425,7 +36643,7 @@
                 </a:solidFill>
                 <a:latin typeface="DejaVu Sans"/>
               </a:rPr>
-              <a:t>Cellar valuation</a:t>
+              <a:t>Wine cellar</a:t>
             </a:r>
           </a:p>
         </p:txBody>
@@ -36524,7 +36742,7 @@
       </p:sp>
       <p:pic>
         <p:nvPicPr>
-          <p:cNvPr id="5" name="Picture 4" descr="kav-degerleme.png"/>
+          <p:cNvPr id="5" name="Picture 4" descr="sarap-kavi.png"/>
           <p:cNvPicPr>
             <a:picLocks noChangeAspect="1"/>
           </p:cNvPicPr>
@@ -36580,7 +36798,7 @@
                 </a:solidFill>
                 <a:latin typeface="DejaVu Sans"/>
               </a:rPr>
-              <a:t>Financial snapshot of the cellar at cost and list value</a:t>
+              <a:t>Bottle and by-the-glass stock, drinking windows and pricing</a:t>
             </a:r>
           </a:p>
         </p:txBody>
@@ -36723,7 +36941,7 @@
                 </a:solidFill>
                 <a:latin typeface="DejaVu Sans"/>
               </a:rPr>
-              <a:t>Menu and recipes</a:t>
+              <a:t>Cellar valuation</a:t>
             </a:r>
           </a:p>
         </p:txBody>
@@ -36822,7 +37040,7 @@
       </p:sp>
       <p:pic>
         <p:nvPicPr>
-          <p:cNvPr id="5" name="Picture 4" descr="menu.png"/>
+          <p:cNvPr id="5" name="Picture 4" descr="kav-degerleme.png"/>
           <p:cNvPicPr>
             <a:picLocks noChangeAspect="1"/>
           </p:cNvPicPr>
@@ -36878,7 +37096,7 @@
                 </a:solidFill>
                 <a:latin typeface="DejaVu Sans"/>
               </a:rPr>
-              <a:t>Menu management with portion cost, allergens and nutrition labels</a:t>
+              <a:t>Financial snapshot of the cellar at cost and list value</a:t>
             </a:r>
           </a:p>
         </p:txBody>
@@ -37021,7 +37239,7 @@
                 </a:solidFill>
                 <a:latin typeface="DejaVu Sans"/>
               </a:rPr>
-              <a:t>Inventory and purchasing</a:t>
+              <a:t>Menu and recipes</a:t>
             </a:r>
           </a:p>
         </p:txBody>
@@ -37120,7 +37338,7 @@
       </p:sp>
       <p:pic>
         <p:nvPicPr>
-          <p:cNvPr id="5" name="Picture 4" descr="stok.png"/>
+          <p:cNvPr id="5" name="Picture 4" descr="menu.png"/>
           <p:cNvPicPr>
             <a:picLocks noChangeAspect="1"/>
           </p:cNvPicPr>
@@ -37176,7 +37394,7 @@
                 </a:solidFill>
                 <a:latin typeface="DejaVu Sans"/>
               </a:rPr>
-              <a:t>FIFO/FEFO lot tracking, receiving, stock counts and waste flows</a:t>
+              <a:t>Menu management with portion cost, allergens and nutrition labels</a:t>
             </a:r>
           </a:p>
         </p:txBody>
@@ -37319,7 +37537,7 @@
                 </a:solidFill>
                 <a:latin typeface="DejaVu Sans"/>
               </a:rPr>
-              <a:t>Customer relations</a:t>
+              <a:t>Inventory and purchasing</a:t>
             </a:r>
           </a:p>
         </p:txBody>
@@ -37418,7 +37636,7 @@
       </p:sp>
       <p:pic>
         <p:nvPicPr>
-          <p:cNvPr id="5" name="Picture 4" descr="crm.png"/>
+          <p:cNvPr id="5" name="Picture 4" descr="stok.png"/>
           <p:cNvPicPr>
             <a:picLocks noChangeAspect="1"/>
           </p:cNvPicPr>
@@ -37474,7 +37692,7 @@
                 </a:solidFill>
                 <a:latin typeface="DejaVu Sans"/>
               </a:rPr>
-              <a:t>Consent management, export, anonymisation and loyalty — GDPR flows built in</a:t>
+              <a:t>FIFO/FEFO lot tracking, receiving, stock counts and waste flows</a:t>
             </a:r>
           </a:p>
         </p:txBody>
@@ -37617,7 +37835,7 @@
                 </a:solidFill>
                 <a:latin typeface="DejaVu Sans"/>
               </a:rPr>
-              <a:t>Reports</a:t>
+              <a:t>Customer relations</a:t>
             </a:r>
           </a:p>
         </p:txBody>
@@ -37716,7 +37934,7 @@
       </p:sp>
       <p:pic>
         <p:nvPicPr>
-          <p:cNvPr id="5" name="Picture 4" descr="raporlar.png"/>
+          <p:cNvPr id="5" name="Picture 4" descr="crm.png"/>
           <p:cNvPicPr>
             <a:picLocks noChangeAspect="1"/>
           </p:cNvPicPr>
@@ -37772,7 +37990,7 @@
                 </a:solidFill>
                 <a:latin typeface="DejaVu Sans"/>
               </a:rPr>
-              <a:t>13 ready-made reports · PDF, Excel and CSV export</a:t>
+              <a:t>Consent management, export, anonymisation and loyalty — GDPR flows built in</a:t>
             </a:r>
           </a:p>
         </p:txBody>
@@ -37915,7 +38133,7 @@
                 </a:solidFill>
                 <a:latin typeface="DejaVu Sans"/>
               </a:rPr>
-              <a:t>AI assistant</a:t>
+              <a:t>Reports</a:t>
             </a:r>
           </a:p>
         </p:txBody>
@@ -38014,7 +38232,7 @@
       </p:sp>
       <p:pic>
         <p:nvPicPr>
-          <p:cNvPr id="5" name="Picture 4" descr="yapay-zeka.png"/>
+          <p:cNvPr id="5" name="Picture 4" descr="raporlar.png"/>
           <p:cNvPicPr>
             <a:picLocks noChangeAspect="1"/>
           </p:cNvPicPr>
@@ -38070,7 +38288,7 @@
                 </a:solidFill>
                 <a:latin typeface="DejaVu Sans"/>
               </a:rPr>
-              <a:t>Local-first providers, masking and budget control; it advises, never decides</a:t>
+              <a:t>13 ready-made reports · PDF, Excel and CSV export</a:t>
             </a:r>
           </a:p>
         </p:txBody>
@@ -38213,7 +38431,7 @@
                 </a:solidFill>
                 <a:latin typeface="DejaVu Sans"/>
               </a:rPr>
-              <a:t>Training centre</a:t>
+              <a:t>AI assistant</a:t>
             </a:r>
           </a:p>
         </p:txBody>
@@ -38312,7 +38530,7 @@
       </p:sp>
       <p:pic>
         <p:nvPicPr>
-          <p:cNvPr id="5" name="Picture 4" descr="egitim.png"/>
+          <p:cNvPr id="5" name="Picture 4" descr="yapay-zeka.png"/>
           <p:cNvPicPr>
             <a:picLocks noChangeAspect="1"/>
           </p:cNvPicPr>
@@ -38368,7 +38586,7 @@
                 </a:solidFill>
                 <a:latin typeface="DejaVu Sans"/>
               </a:rPr>
-              <a:t>Role-based staff training modules and lessons</a:t>
+              <a:t>Local-first providers, masking and budget control; it advises, never decides</a:t>
             </a:r>
           </a:p>
         </p:txBody>
@@ -38479,14 +38697,53 @@
       <p:grpSpPr/>
       <p:sp>
         <p:nvSpPr>
-          <p:cNvPr id="2" name="Rectangle 1"/>
+          <p:cNvPr id="2" name="TextBox 1"/>
+          <p:cNvSpPr txBox="1"/>
+          <p:nvPr/>
+        </p:nvSpPr>
+        <p:spPr>
+          <a:xfrm>
+            <a:off x="777240" y="566928"/>
+            <a:ext cx="10607040" cy="914400"/>
+          </a:xfrm>
+          <a:prstGeom prst="rect">
+            <a:avLst/>
+          </a:prstGeom>
+          <a:noFill/>
+        </p:spPr>
+        <p:txBody>
+          <a:bodyPr wrap="square" anchor="t" lIns="0" rIns="0" tIns="0" bIns="0">
+            <a:spAutoFit/>
+          </a:bodyPr>
+          <a:lstStyle/>
+          <a:p>
+            <a:pPr algn="l">
+              <a:spcAft>
+                <a:spcPts val="0"/>
+              </a:spcAft>
+            </a:pPr>
+            <a:r>
+              <a:rPr sz="3000" b="1">
+                <a:solidFill>
+                  <a:srgbClr val="F2EAEC"/>
+                </a:solidFill>
+                <a:latin typeface="DejaVu Sans"/>
+              </a:rPr>
+              <a:t>Training centre</a:t>
+            </a:r>
+          </a:p>
+        </p:txBody>
+      </p:sp>
+      <p:sp>
+        <p:nvSpPr>
+          <p:cNvPr id="3" name="Rectangle 2"/>
           <p:cNvSpPr/>
           <p:nvPr/>
         </p:nvSpPr>
         <p:spPr>
           <a:xfrm>
-            <a:off x="0" y="0"/>
-            <a:ext cx="256032" cy="6858000"/>
+            <a:off x="777240" y="1572768"/>
+            <a:ext cx="1371600" cy="38100"/>
           </a:xfrm>
           <a:prstGeom prst="rect">
             <a:avLst/>
@@ -38523,6 +38780,265 @@
       </p:sp>
       <p:sp>
         <p:nvSpPr>
+          <p:cNvPr id="4" name="Rounded Rectangle 3"/>
+          <p:cNvSpPr/>
+          <p:nvPr/>
+        </p:nvSpPr>
+        <p:spPr>
+          <a:xfrm>
+            <a:off x="2815437" y="1801368"/>
+            <a:ext cx="6558076" cy="4133087"/>
+          </a:xfrm>
+          <a:prstGeom prst="roundRect">
+            <a:avLst>
+              <a:gd name="adj" fmla="val 6000"/>
+            </a:avLst>
+          </a:prstGeom>
+          <a:solidFill>
+            <a:srgbClr val="241419"/>
+          </a:solidFill>
+          <a:ln w="12700">
+            <a:solidFill>
+              <a:srgbClr val="3D2530"/>
+            </a:solidFill>
+          </a:ln>
+          <a:effectLst/>
+        </p:spPr>
+        <p:style>
+          <a:lnRef idx="1">
+            <a:schemeClr val="accent1"/>
+          </a:lnRef>
+          <a:fillRef idx="3">
+            <a:schemeClr val="accent1"/>
+          </a:fillRef>
+          <a:effectRef idx="2">
+            <a:schemeClr val="accent1"/>
+          </a:effectRef>
+          <a:fontRef idx="minor">
+            <a:schemeClr val="lt1"/>
+          </a:fontRef>
+        </p:style>
+        <p:txBody>
+          <a:bodyPr rtlCol="0" anchor="ctr"/>
+          <a:lstStyle/>
+          <a:p>
+            <a:pPr algn="ctr"/>
+          </a:p>
+        </p:txBody>
+      </p:sp>
+      <p:pic>
+        <p:nvPicPr>
+          <p:cNvPr id="5" name="Picture 4" descr="egitim.png"/>
+          <p:cNvPicPr>
+            <a:picLocks noChangeAspect="1"/>
+          </p:cNvPicPr>
+          <p:nvPr/>
+        </p:nvPicPr>
+        <p:blipFill>
+          <a:blip r:embed="rId2"/>
+          <a:stretch>
+            <a:fillRect/>
+          </a:stretch>
+        </p:blipFill>
+        <p:spPr>
+          <a:xfrm>
+            <a:off x="2861157" y="1847088"/>
+            <a:ext cx="6466636" cy="4041648"/>
+          </a:xfrm>
+          <a:prstGeom prst="rect">
+            <a:avLst/>
+          </a:prstGeom>
+        </p:spPr>
+      </p:pic>
+      <p:sp>
+        <p:nvSpPr>
+          <p:cNvPr id="6" name="TextBox 5"/>
+          <p:cNvSpPr txBox="1"/>
+          <p:nvPr/>
+        </p:nvSpPr>
+        <p:spPr>
+          <a:xfrm>
+            <a:off x="777240" y="6016751"/>
+            <a:ext cx="10607040" cy="457200"/>
+          </a:xfrm>
+          <a:prstGeom prst="rect">
+            <a:avLst/>
+          </a:prstGeom>
+          <a:noFill/>
+        </p:spPr>
+        <p:txBody>
+          <a:bodyPr wrap="square" anchor="t" lIns="0" rIns="0" tIns="0" bIns="0">
+            <a:spAutoFit/>
+          </a:bodyPr>
+          <a:lstStyle/>
+          <a:p>
+            <a:pPr algn="l">
+              <a:spcAft>
+                <a:spcPts val="0"/>
+              </a:spcAft>
+            </a:pPr>
+            <a:r>
+              <a:rPr sz="1150" b="0">
+                <a:solidFill>
+                  <a:srgbClr val="B9A7AE"/>
+                </a:solidFill>
+                <a:latin typeface="DejaVu Sans"/>
+              </a:rPr>
+              <a:t>Role-based staff training modules and lessons</a:t>
+            </a:r>
+          </a:p>
+        </p:txBody>
+      </p:sp>
+      <p:sp>
+        <p:nvSpPr>
+          <p:cNvPr id="7" name="TextBox 6"/>
+          <p:cNvSpPr txBox="1"/>
+          <p:nvPr/>
+        </p:nvSpPr>
+        <p:spPr>
+          <a:xfrm>
+            <a:off x="777240" y="6327648"/>
+            <a:ext cx="7315200" cy="320040"/>
+          </a:xfrm>
+          <a:prstGeom prst="rect">
+            <a:avLst/>
+          </a:prstGeom>
+          <a:noFill/>
+        </p:spPr>
+        <p:txBody>
+          <a:bodyPr wrap="square" anchor="t" lIns="0" rIns="0" tIns="0" bIns="0">
+            <a:spAutoFit/>
+          </a:bodyPr>
+          <a:lstStyle/>
+          <a:p>
+            <a:pPr algn="l">
+              <a:spcAft>
+                <a:spcPts val="0"/>
+              </a:spcAft>
+            </a:pPr>
+            <a:r>
+              <a:rPr sz="900" b="0">
+                <a:solidFill>
+                  <a:srgbClr val="B9A7AE"/>
+                </a:solidFill>
+                <a:latin typeface="DejaVu Sans"/>
+              </a:rPr>
+              <a:t>Wine House · Aziz Şekerdil · 2026</a:t>
+            </a:r>
+          </a:p>
+        </p:txBody>
+      </p:sp>
+      <p:sp>
+        <p:nvSpPr>
+          <p:cNvPr id="8" name="TextBox 7"/>
+          <p:cNvSpPr txBox="1"/>
+          <p:nvPr/>
+        </p:nvSpPr>
+        <p:spPr>
+          <a:xfrm>
+            <a:off x="10424160" y="6327648"/>
+            <a:ext cx="960120" cy="320040"/>
+          </a:xfrm>
+          <a:prstGeom prst="rect">
+            <a:avLst/>
+          </a:prstGeom>
+          <a:noFill/>
+        </p:spPr>
+        <p:txBody>
+          <a:bodyPr wrap="square" anchor="t" lIns="0" rIns="0" tIns="0" bIns="0">
+            <a:spAutoFit/>
+          </a:bodyPr>
+          <a:lstStyle/>
+          <a:p>
+            <a:pPr algn="r">
+              <a:spcAft>
+                <a:spcPts val="0"/>
+              </a:spcAft>
+            </a:pPr>
+            <a:r>
+              <a:rPr sz="1000" b="0">
+                <a:solidFill>
+                  <a:srgbClr val="B9A7AE"/>
+                </a:solidFill>
+                <a:latin typeface="DejaVu Sans"/>
+              </a:rPr>
+              <a:t>57</a:t>
+            </a:r>
+          </a:p>
+        </p:txBody>
+      </p:sp>
+    </p:spTree>
+  </p:cSld>
+  <p:clrMapOvr>
+    <a:masterClrMapping/>
+  </p:clrMapOvr>
+</p:sld>
+</file>
+
+<file path=ppt/slides/slide58.xml><?xml version="1.0" encoding="utf-8"?>
+<p:sld xmlns:a="http://schemas.openxmlformats.org/drawingml/2006/main" xmlns:p="http://schemas.openxmlformats.org/presentationml/2006/main" xmlns:r="http://schemas.openxmlformats.org/officeDocument/2006/relationships">
+  <p:cSld>
+    <p:bg>
+      <p:bgPr>
+        <a:solidFill>
+          <a:srgbClr val="1A0E14"/>
+        </a:solidFill>
+        <a:effectLst/>
+      </p:bgPr>
+    </p:bg>
+    <p:spTree>
+      <p:nvGrpSpPr>
+        <p:cNvPr id="1" name=""/>
+        <p:cNvGrpSpPr/>
+        <p:nvPr/>
+      </p:nvGrpSpPr>
+      <p:grpSpPr/>
+      <p:sp>
+        <p:nvSpPr>
+          <p:cNvPr id="2" name="Rectangle 1"/>
+          <p:cNvSpPr/>
+          <p:nvPr/>
+        </p:nvSpPr>
+        <p:spPr>
+          <a:xfrm>
+            <a:off x="0" y="0"/>
+            <a:ext cx="256032" cy="6858000"/>
+          </a:xfrm>
+          <a:prstGeom prst="rect">
+            <a:avLst/>
+          </a:prstGeom>
+          <a:solidFill>
+            <a:srgbClr val="C8A45C"/>
+          </a:solidFill>
+          <a:ln>
+            <a:noFill/>
+          </a:ln>
+          <a:effectLst/>
+        </p:spPr>
+        <p:style>
+          <a:lnRef idx="1">
+            <a:schemeClr val="accent1"/>
+          </a:lnRef>
+          <a:fillRef idx="3">
+            <a:schemeClr val="accent1"/>
+          </a:fillRef>
+          <a:effectRef idx="2">
+            <a:schemeClr val="accent1"/>
+          </a:effectRef>
+          <a:fontRef idx="minor">
+            <a:schemeClr val="lt1"/>
+          </a:fontRef>
+        </p:style>
+        <p:txBody>
+          <a:bodyPr rtlCol="0" anchor="ctr"/>
+          <a:lstStyle/>
+          <a:p>
+            <a:pPr algn="ctr"/>
+          </a:p>
+        </p:txBody>
+      </p:sp>
+      <p:sp>
+        <p:nvSpPr>
           <p:cNvPr id="3" name="Rectangle 2"/>
           <p:cNvSpPr/>
           <p:nvPr/>
@@ -38902,7 +39418,7 @@
                 </a:solidFill>
                 <a:latin typeface="DejaVu Sans"/>
               </a:rPr>
-              <a:t>57</a:t>
+              <a:t>58</a:t>
             </a:r>
           </a:p>
         </p:txBody>
@@ -39133,7 +39649,7 @@
                 </a:solidFill>
                 <a:latin typeface="DejaVu Sans"/>
               </a:rPr>
-              <a:t>6 / 57</a:t>
+              <a:t>6 / 58</a:t>
             </a:r>
           </a:p>
         </p:txBody>

</xml_diff>